<commit_message>
fix: place regenerated artifacts in correct gtm/ folders (new $1,500 pricing)
Co-Authored-By: Claude Opus 4.8 <noreply@anthropic.com>
</commit_message>
<xml_diff>
--- a/gtm/06-collateral/Verispect-Pitch-Deck.pptx
+++ b/gtm/06-collateral/Verispect-Pitch-Deck.pptx
@@ -3766,7 +3766,7 @@
                 </a:solidFill>
                 <a:latin typeface="Calibri"/>
               </a:rPr>
-              <a:t>Free wedge → Pro self-serve → Enterprise. ~88–90% gross margin.</a:t>
+              <a:t>One product, zero config. Premium, value-based. ~95% gross margin.</a:t>
             </a:r>
           </a:p>
         </p:txBody>
@@ -3839,7 +3839,7 @@
                 </a:solidFill>
                 <a:latin typeface="Calibri"/>
               </a:rPr>
-              <a:t>€0</a:t>
+              <a:t>$0</a:t>
             </a:r>
           </a:p>
           <a:p>
@@ -3855,7 +3855,7 @@
                 </a:solidFill>
                 <a:latin typeface="Calibri"/>
               </a:rPr>
-              <a:t>10k calls, 1 report</a:t>
+              <a:t>AI Act snapshot — lead magnet</a:t>
             </a:r>
           </a:p>
         </p:txBody>
@@ -3912,7 +3912,7 @@
                 </a:solidFill>
                 <a:latin typeface="Calibri"/>
               </a:rPr>
-              <a:t>Pro</a:t>
+              <a:t>Verispect</a:t>
             </a:r>
           </a:p>
           <a:p>
@@ -3928,7 +3928,7 @@
                 </a:solidFill>
                 <a:latin typeface="Calibri"/>
               </a:rPr>
-              <a:t>€99/mo</a:t>
+              <a:t>$1,500/mo</a:t>
             </a:r>
           </a:p>
           <a:p>
@@ -3944,7 +3944,7 @@
                 </a:solidFill>
                 <a:latin typeface="Calibri"/>
               </a:rPr>
-              <a:t>250k calls, all probes, alerts</a:t>
+              <a:t>zero config · everything · always-current audit pack</a:t>
             </a:r>
           </a:p>
         </p:txBody>
@@ -4001,7 +4001,7 @@
                 </a:solidFill>
                 <a:latin typeface="Calibri"/>
               </a:rPr>
-              <a:t>Business</a:t>
+              <a:t>Founding 20</a:t>
             </a:r>
           </a:p>
           <a:p>
@@ -4017,7 +4017,7 @@
                 </a:solidFill>
                 <a:latin typeface="Calibri"/>
               </a:rPr>
-              <a:t>€399/mo</a:t>
+              <a:t>$1,500 locked</a:t>
             </a:r>
           </a:p>
           <a:p>
@@ -4033,7 +4033,7 @@
                 </a:solidFill>
                 <a:latin typeface="Calibri"/>
               </a:rPr>
-              <a:t>2M calls, 10 models, unlimited reports</a:t>
+              <a:t>for life, before it rises to $2,500</a:t>
             </a:r>
           </a:p>
         </p:txBody>
@@ -4106,7 +4106,7 @@
                 </a:solidFill>
                 <a:latin typeface="Calibri"/>
               </a:rPr>
-              <a:t>€2–10k/mo</a:t>
+              <a:t>from $2,500/mo</a:t>
             </a:r>
           </a:p>
           <a:p>
@@ -4122,7 +4122,7 @@
                 </a:solidFill>
                 <a:latin typeface="Calibri"/>
               </a:rPr>
-              <a:t>white-label, custom probes, SLA, audit support</a:t>
+              <a:t>multi-entity · SSO · SLA · audit support</a:t>
             </a:r>
           </a:p>
         </p:txBody>

</xml_diff>